<commit_message>
Atualização de viaturas descaracterizadas
</commit_message>
<xml_diff>
--- a/Documentacao/Apresentação Módulo Operadores.pptx
+++ b/Documentacao/Apresentação Módulo Operadores.pptx
@@ -5,7 +5,7 @@
     <p:sldMasterId id="2147483648" r:id="rId1"/>
   </p:sldMasterIdLst>
   <p:notesMasterIdLst>
-    <p:notesMasterId r:id="rId28"/>
+    <p:notesMasterId r:id="rId30"/>
   </p:notesMasterIdLst>
   <p:sldIdLst>
     <p:sldId id="267" r:id="rId2"/>
@@ -34,6 +34,8 @@
     <p:sldId id="274" r:id="rId25"/>
     <p:sldId id="275" r:id="rId26"/>
     <p:sldId id="276" r:id="rId27"/>
+    <p:sldId id="290" r:id="rId28"/>
+    <p:sldId id="295" r:id="rId29"/>
   </p:sldIdLst>
   <p:sldSz cx="12192000" cy="6858000"/>
   <p:notesSz cx="6858000" cy="12192000"/>
@@ -1367,6 +1369,101 @@
 </p:sldLayout>
 </file>
 
+<file path=ppt/slideLayouts/slideLayout2.xml><?xml version="1.0" encoding="utf-8"?>
+<p:sldLayout xmlns:a="http://schemas.openxmlformats.org/drawingml/2006/main" xmlns:r="http://schemas.openxmlformats.org/officeDocument/2006/relationships" xmlns:p="http://schemas.openxmlformats.org/presentationml/2006/main" type="blank">
+  <p:cSld name="Em Branco">
+    <p:spTree>
+      <p:nvGrpSpPr>
+        <p:cNvPr id="1" name=""/>
+        <p:cNvGrpSpPr/>
+        <p:nvPr/>
+      </p:nvGrpSpPr>
+      <p:grpSpPr>
+        <a:xfrm>
+          <a:off x="0" y="0"/>
+          <a:ext cx="0" cy="0"/>
+          <a:chOff x="0" y="0"/>
+          <a:chExt cx="0" cy="0"/>
+        </a:xfrm>
+      </p:grpSpPr>
+      <p:sp>
+        <p:nvSpPr>
+          <p:cNvPr id="2" name="Date Placeholder 1"/>
+          <p:cNvSpPr>
+            <a:spLocks noGrp="1"/>
+          </p:cNvSpPr>
+          <p:nvPr>
+            <p:ph type="dt" sz="half" idx="10"/>
+          </p:nvPr>
+        </p:nvSpPr>
+        <p:spPr/>
+        <p:txBody>
+          <a:bodyPr/>
+          <a:lstStyle/>
+          <a:p>
+            <a:fld id="{6A5335B1-82CA-4E15-A5D8-FED425F1DBD2}" type="datetimeFigureOut">
+              <a:rPr lang="pt-BR" smtClean="0"/>
+              <a:t>20/10/2026</a:t>
+            </a:fld>
+            <a:endParaRPr lang="pt-BR"/>
+          </a:p>
+        </p:txBody>
+      </p:sp>
+      <p:sp>
+        <p:nvSpPr>
+          <p:cNvPr id="3" name="Footer Placeholder 2"/>
+          <p:cNvSpPr>
+            <a:spLocks noGrp="1"/>
+          </p:cNvSpPr>
+          <p:nvPr>
+            <p:ph type="ftr" sz="quarter" idx="11"/>
+          </p:nvPr>
+        </p:nvSpPr>
+        <p:spPr/>
+        <p:txBody>
+          <a:bodyPr/>
+          <a:lstStyle/>
+          <a:p>
+            <a:endParaRPr lang="pt-BR"/>
+          </a:p>
+        </p:txBody>
+      </p:sp>
+      <p:sp>
+        <p:nvSpPr>
+          <p:cNvPr id="4" name="Slide Number Placeholder 3"/>
+          <p:cNvSpPr>
+            <a:spLocks noGrp="1"/>
+          </p:cNvSpPr>
+          <p:nvPr>
+            <p:ph type="sldNum" sz="quarter" idx="12"/>
+          </p:nvPr>
+        </p:nvSpPr>
+        <p:spPr/>
+        <p:txBody>
+          <a:bodyPr/>
+          <a:lstStyle/>
+          <a:p>
+            <a:fld id="{445F9310-BB4F-4F9D-8475-C127F45CE17A}" type="slidenum">
+              <a:rPr lang="pt-BR" smtClean="0"/>
+              <a:t>‹nº›</a:t>
+            </a:fld>
+            <a:endParaRPr lang="pt-BR"/>
+          </a:p>
+        </p:txBody>
+      </p:sp>
+    </p:spTree>
+    <p:extLst>
+      <p:ext uri="{BB962C8B-B14F-4D97-AF65-F5344CB8AC3E}">
+        <p14:creationId xmlns:p14="http://schemas.microsoft.com/office/powerpoint/2010/main" val="4210618078"/>
+      </p:ext>
+    </p:extLst>
+  </p:cSld>
+  <p:clrMapOvr>
+    <a:masterClrMapping/>
+  </p:clrMapOvr>
+</p:sldLayout>
+</file>
+
 <file path=ppt/slideMasters/slideMaster1.xml><?xml version="1.0" encoding="utf-8"?>
 <p:sldMaster xmlns:a="http://schemas.openxmlformats.org/drawingml/2006/main" xmlns:r="http://schemas.openxmlformats.org/officeDocument/2006/relationships" xmlns:p="http://schemas.openxmlformats.org/presentationml/2006/main">
   <p:cSld>
@@ -1394,6 +1491,7 @@
   <p:clrMap bg1="lt1" tx1="dk1" bg2="lt2" tx2="dk2" accent1="accent1" accent2="accent2" accent3="accent3" accent4="accent4" accent5="accent5" accent6="accent6" hlink="hlink" folHlink="folHlink"/>
   <p:sldLayoutIdLst>
     <p:sldLayoutId id="2147483649" r:id="rId1"/>
+    <p:sldLayoutId id="2147483650" r:id="rId2"/>
   </p:sldLayoutIdLst>
   <p:hf sldNum="0" hdr="0" ftr="0" dt="0"/>
   <p:txStyles>
@@ -12719,6 +12817,854 @@
           </a:p>
         </p:txBody>
       </p:sp>
+    </p:spTree>
+  </p:cSld>
+  <p:clrMapOvr>
+    <a:masterClrMapping/>
+  </p:clrMapOvr>
+</p:sld>
+</file>
+
+<file path=ppt/slides/slide27.xml><?xml version="1.0" encoding="utf-8"?>
+<p:sld xmlns:a="http://schemas.openxmlformats.org/drawingml/2006/main" xmlns:r="http://schemas.openxmlformats.org/officeDocument/2006/relationships" xmlns:p="http://schemas.openxmlformats.org/presentationml/2006/main">
+  <p:cSld>
+    <p:spTree>
+      <p:nvGrpSpPr>
+        <p:cNvPr id="1" name=""/>
+        <p:cNvGrpSpPr/>
+        <p:nvPr/>
+      </p:nvGrpSpPr>
+      <p:grpSpPr>
+        <a:xfrm>
+          <a:off x="0" y="0"/>
+          <a:ext cx="0" cy="0"/>
+          <a:chOff x="0" y="0"/>
+          <a:chExt cx="0" cy="0"/>
+        </a:xfrm>
+      </p:grpSpPr>
+      <p:sp>
+        <p:nvSpPr>
+          <p:cNvPr id="4" name="Rounded Rectangle 3"/>
+          <p:cNvSpPr/>
+          <p:nvPr/>
+        </p:nvSpPr>
+        <p:spPr>
+          <a:xfrm>
+            <a:off x="731520" y="1874519"/>
+            <a:ext cx="5212080" cy="3520440"/>
+          </a:xfrm>
+          <a:prstGeom prst="roundRect">
+            <a:avLst/>
+          </a:prstGeom>
+          <a:solidFill>
+            <a:srgbClr val="191F26"/>
+          </a:solidFill>
+          <a:ln w="19050">
+            <a:solidFill>
+              <a:srgbClr val="B28B4E"/>
+            </a:solidFill>
+          </a:ln>
+        </p:spPr>
+        <p:style>
+          <a:lnRef idx="1">
+            <a:schemeClr val="accent1"/>
+          </a:lnRef>
+          <a:fillRef idx="3">
+            <a:schemeClr val="accent1"/>
+          </a:fillRef>
+          <a:effectRef idx="2">
+            <a:schemeClr val="accent1"/>
+          </a:effectRef>
+          <a:fontRef idx="minor">
+            <a:schemeClr val="lt1"/>
+          </a:fontRef>
+        </p:style>
+        <p:txBody>
+          <a:bodyPr rtlCol="0" anchor="ctr"/>
+          <a:lstStyle/>
+          <a:p>
+            <a:pPr algn="ctr">
+              <a:defRPr sz="1800" b="1">
+                <a:solidFill>
+                  <a:srgbClr val="B28B4E"/>
+                </a:solidFill>
+                <a:latin typeface="Arial"/>
+              </a:defRPr>
+            </a:pPr>
+            <a:r>
+              <a:rPr lang="pt-BR" noProof="0"/>
+              <a:t>OBJETIVO</a:t>
+            </a:r>
+            <a:endParaRPr lang="pt-BR" noProof="0" dirty="0"/>
+          </a:p>
+          <a:p>
+            <a:pPr>
+              <a:spcBef>
+                <a:spcPts val="600"/>
+              </a:spcBef>
+              <a:defRPr sz="1500">
+                <a:solidFill>
+                  <a:srgbClr val="F5F5F5"/>
+                </a:solidFill>
+                <a:latin typeface="Arial"/>
+              </a:defRPr>
+            </a:pPr>
+            <a:r>
+              <a:rPr lang="pt-BR" noProof="0" dirty="0"/>
+              <a:t>• Registrar afastamentos e impedimentos dos operadores.</a:t>
+            </a:r>
+          </a:p>
+          <a:p>
+            <a:pPr>
+              <a:spcBef>
+                <a:spcPts val="600"/>
+              </a:spcBef>
+              <a:defRPr sz="1500">
+                <a:solidFill>
+                  <a:srgbClr val="F5F5F5"/>
+                </a:solidFill>
+                <a:latin typeface="Arial"/>
+              </a:defRPr>
+            </a:pPr>
+            <a:r>
+              <a:rPr lang="pt-BR" noProof="0" dirty="0"/>
+              <a:t>• Consultar a situação do operador em uma data de referência.</a:t>
+            </a:r>
+          </a:p>
+          <a:p>
+            <a:pPr>
+              <a:spcBef>
+                <a:spcPts val="600"/>
+              </a:spcBef>
+              <a:defRPr sz="1500">
+                <a:solidFill>
+                  <a:srgbClr val="F5F5F5"/>
+                </a:solidFill>
+                <a:latin typeface="Arial"/>
+              </a:defRPr>
+            </a:pPr>
+            <a:r>
+              <a:rPr lang="pt-BR" noProof="0" dirty="0"/>
+              <a:t>• Centralizar as regras de elegibilidade antes da integração com as operações.</a:t>
+            </a:r>
+          </a:p>
+          <a:p>
+            <a:pPr>
+              <a:spcBef>
+                <a:spcPts val="600"/>
+              </a:spcBef>
+              <a:defRPr sz="1500">
+                <a:solidFill>
+                  <a:srgbClr val="F5F5F5"/>
+                </a:solidFill>
+                <a:latin typeface="Arial"/>
+              </a:defRPr>
+            </a:pPr>
+            <a:r>
+              <a:rPr lang="pt-BR" noProof="0" dirty="0"/>
+              <a:t>• Evitar candidaturas incompatíveis com as regras administrativas do SVG.</a:t>
+            </a:r>
+          </a:p>
+        </p:txBody>
+      </p:sp>
+      <p:sp>
+        <p:nvSpPr>
+          <p:cNvPr id="5" name="Rounded Rectangle 4"/>
+          <p:cNvSpPr/>
+          <p:nvPr/>
+        </p:nvSpPr>
+        <p:spPr>
+          <a:xfrm>
+            <a:off x="6263640" y="1874519"/>
+            <a:ext cx="5212080" cy="3520440"/>
+          </a:xfrm>
+          <a:prstGeom prst="roundRect">
+            <a:avLst/>
+          </a:prstGeom>
+          <a:solidFill>
+            <a:srgbClr val="191F26"/>
+          </a:solidFill>
+          <a:ln w="19050">
+            <a:solidFill>
+              <a:srgbClr val="368C5C"/>
+            </a:solidFill>
+          </a:ln>
+        </p:spPr>
+        <p:style>
+          <a:lnRef idx="1">
+            <a:schemeClr val="accent1"/>
+          </a:lnRef>
+          <a:fillRef idx="3">
+            <a:schemeClr val="accent1"/>
+          </a:fillRef>
+          <a:effectRef idx="2">
+            <a:schemeClr val="accent1"/>
+          </a:effectRef>
+          <a:fontRef idx="minor">
+            <a:schemeClr val="lt1"/>
+          </a:fontRef>
+        </p:style>
+        <p:txBody>
+          <a:bodyPr rtlCol="0" anchor="ctr"/>
+          <a:lstStyle/>
+          <a:p>
+            <a:pPr algn="ctr">
+              <a:defRPr sz="1800" b="1">
+                <a:solidFill>
+                  <a:srgbClr val="368C5C"/>
+                </a:solidFill>
+                <a:latin typeface="Arial"/>
+              </a:defRPr>
+            </a:pPr>
+            <a:r>
+              <a:rPr lang="pt-BR" noProof="0" dirty="0"/>
+              <a:t>EXEMPLO</a:t>
+            </a:r>
+          </a:p>
+          <a:p>
+            <a:pPr>
+              <a:spcBef>
+                <a:spcPts val="600"/>
+              </a:spcBef>
+              <a:defRPr sz="1500">
+                <a:solidFill>
+                  <a:srgbClr val="F5F5F5"/>
+                </a:solidFill>
+                <a:latin typeface="Arial"/>
+              </a:defRPr>
+            </a:pPr>
+            <a:r>
+              <a:rPr lang="pt-BR" noProof="0" dirty="0"/>
+              <a:t>• Afastamento: 01/10/2026 a 15/10/2026.</a:t>
+            </a:r>
+          </a:p>
+          <a:p>
+            <a:pPr>
+              <a:spcBef>
+                <a:spcPts val="600"/>
+              </a:spcBef>
+              <a:defRPr sz="1500">
+                <a:solidFill>
+                  <a:srgbClr val="F5F5F5"/>
+                </a:solidFill>
+                <a:latin typeface="Arial"/>
+              </a:defRPr>
+            </a:pPr>
+            <a:r>
+              <a:rPr lang="pt-BR" noProof="0" dirty="0"/>
+              <a:t>• Operação: 02/10/2026.</a:t>
+            </a:r>
+          </a:p>
+          <a:p>
+            <a:pPr>
+              <a:spcBef>
+                <a:spcPts val="600"/>
+              </a:spcBef>
+              <a:defRPr sz="1500">
+                <a:solidFill>
+                  <a:srgbClr val="F5F5F5"/>
+                </a:solidFill>
+                <a:latin typeface="Arial"/>
+              </a:defRPr>
+            </a:pPr>
+            <a:r>
+              <a:rPr lang="pt-BR" noProof="0" dirty="0"/>
+              <a:t>• Resultado: operador não elegível naquela data.</a:t>
+            </a:r>
+          </a:p>
+          <a:p>
+            <a:pPr>
+              <a:spcBef>
+                <a:spcPts val="600"/>
+              </a:spcBef>
+              <a:defRPr sz="1500">
+                <a:solidFill>
+                  <a:srgbClr val="F5F5F5"/>
+                </a:solidFill>
+                <a:latin typeface="Arial"/>
+              </a:defRPr>
+            </a:pPr>
+            <a:r>
+              <a:rPr lang="pt-BR" noProof="0" dirty="0"/>
+              <a:t>• Na integração futura, o botão de inclusão/candidatura ficará indisponível e o motivo será exibido.</a:t>
+            </a:r>
+          </a:p>
+        </p:txBody>
+      </p:sp>
+      <p:sp>
+        <p:nvSpPr>
+          <p:cNvPr id="6" name="Rectangle 5"/>
+          <p:cNvSpPr/>
+          <p:nvPr/>
+        </p:nvSpPr>
+        <p:spPr>
+          <a:xfrm>
+            <a:off x="1005840" y="6537960"/>
+            <a:ext cx="10149840" cy="10972"/>
+          </a:xfrm>
+          <a:prstGeom prst="rect">
+            <a:avLst/>
+          </a:prstGeom>
+          <a:solidFill>
+            <a:srgbClr val="B28B4E"/>
+          </a:solidFill>
+          <a:ln>
+            <a:noFill/>
+          </a:ln>
+        </p:spPr>
+        <p:style>
+          <a:lnRef idx="1">
+            <a:schemeClr val="accent1"/>
+          </a:lnRef>
+          <a:fillRef idx="3">
+            <a:schemeClr val="accent1"/>
+          </a:fillRef>
+          <a:effectRef idx="2">
+            <a:schemeClr val="accent1"/>
+          </a:effectRef>
+          <a:fontRef idx="minor">
+            <a:schemeClr val="lt1"/>
+          </a:fontRef>
+        </p:style>
+        <p:txBody>
+          <a:bodyPr rtlCol="0" anchor="ctr"/>
+          <a:lstStyle/>
+          <a:p>
+            <a:pPr algn="ctr"/>
+            <a:endParaRPr lang="pt-BR" noProof="0" dirty="0"/>
+          </a:p>
+        </p:txBody>
+      </p:sp>
+      <p:sp>
+        <p:nvSpPr>
+          <p:cNvPr id="7" name="TextBox 6"/>
+          <p:cNvSpPr txBox="1"/>
+          <p:nvPr/>
+        </p:nvSpPr>
+        <p:spPr>
+          <a:xfrm>
+            <a:off x="3291840" y="6601968"/>
+            <a:ext cx="5577840" cy="228600"/>
+          </a:xfrm>
+          <a:prstGeom prst="rect">
+            <a:avLst/>
+          </a:prstGeom>
+          <a:noFill/>
+        </p:spPr>
+        <p:txBody>
+          <a:bodyPr wrap="none">
+            <a:spAutoFit/>
+          </a:bodyPr>
+          <a:lstStyle/>
+          <a:p>
+            <a:pPr algn="ctr">
+              <a:defRPr sz="850">
+                <a:solidFill>
+                  <a:srgbClr val="AAAAAA"/>
+                </a:solidFill>
+                <a:latin typeface="Arial"/>
+              </a:defRPr>
+            </a:pPr>
+            <a:r>
+              <a:rPr lang="pt-BR" noProof="0" dirty="0"/>
+              <a:t>Op. 73 - 2026 - Divisão de Operações Especiais</a:t>
+            </a:r>
+          </a:p>
+        </p:txBody>
+      </p:sp>
+      <p:sp>
+        <p:nvSpPr>
+          <p:cNvPr id="8" name="CaixaDeTexto 7">
+            <a:extLst>
+              <a:ext uri="{FF2B5EF4-FFF2-40B4-BE49-F238E27FC236}">
+                <a16:creationId xmlns:a16="http://schemas.microsoft.com/office/drawing/2014/main" id="{021F050E-5894-6F12-FABD-B68DD61840A6}"/>
+              </a:ext>
+            </a:extLst>
+          </p:cNvPr>
+          <p:cNvSpPr txBox="1"/>
+          <p:nvPr/>
+        </p:nvSpPr>
+        <p:spPr>
+          <a:xfrm>
+            <a:off x="731520" y="283459"/>
+            <a:ext cx="10744200" cy="630942"/>
+          </a:xfrm>
+          <a:prstGeom prst="rect">
+            <a:avLst/>
+          </a:prstGeom>
+          <a:noFill/>
+        </p:spPr>
+        <p:txBody>
+          <a:bodyPr wrap="square" rtlCol="0">
+            <a:spAutoFit/>
+          </a:bodyPr>
+          <a:lstStyle/>
+          <a:p>
+            <a:pPr algn="ctr"/>
+            <a:r>
+              <a:rPr lang="pt-BR" sz="3500" b="1" dirty="0">
+                <a:latin typeface="Arial" panose="020B0604020202020204" pitchFamily="34" charset="0"/>
+                <a:cs typeface="Arial" panose="020B0604020202020204" pitchFamily="34" charset="0"/>
+              </a:rPr>
+              <a:t>MÓDULO DE AFASTAMENTO</a:t>
+            </a:r>
+          </a:p>
+        </p:txBody>
+      </p:sp>
+      <p:sp>
+        <p:nvSpPr>
+          <p:cNvPr id="9" name="CaixaDeTexto 8">
+            <a:extLst>
+              <a:ext uri="{FF2B5EF4-FFF2-40B4-BE49-F238E27FC236}">
+                <a16:creationId xmlns:a16="http://schemas.microsoft.com/office/drawing/2014/main" id="{A813E2BA-8C5B-262F-9067-1F56062D0AD6}"/>
+              </a:ext>
+            </a:extLst>
+          </p:cNvPr>
+          <p:cNvSpPr txBox="1"/>
+          <p:nvPr/>
+        </p:nvSpPr>
+        <p:spPr>
+          <a:xfrm>
+            <a:off x="1426922" y="830441"/>
+            <a:ext cx="9307676" cy="1200329"/>
+          </a:xfrm>
+          <a:prstGeom prst="rect">
+            <a:avLst/>
+          </a:prstGeom>
+          <a:noFill/>
+        </p:spPr>
+        <p:txBody>
+          <a:bodyPr wrap="none" rtlCol="0">
+            <a:spAutoFit/>
+          </a:bodyPr>
+          <a:lstStyle/>
+          <a:p>
+            <a:r>
+              <a:rPr lang="pt-BR" dirty="0"/>
+              <a:t>Controle preventivo das condições que impedem a prestação do SVG</a:t>
+            </a:r>
+          </a:p>
+          <a:p>
+            <a:r>
+              <a:rPr lang="pt-BR" dirty="0"/>
+              <a:t>Permite o controle para facilitar a compensação de horas</a:t>
+            </a:r>
+          </a:p>
+          <a:p>
+            <a:r>
+              <a:rPr lang="pt-BR" dirty="0"/>
+              <a:t>Evita o operador ser escalado para operações e acionamentos, quando já tem SVG marcado</a:t>
+            </a:r>
+          </a:p>
+          <a:p>
+            <a:endParaRPr lang="pt-BR" dirty="0"/>
+          </a:p>
+        </p:txBody>
+      </p:sp>
+    </p:spTree>
+  </p:cSld>
+  <p:clrMapOvr>
+    <a:masterClrMapping/>
+  </p:clrMapOvr>
+</p:sld>
+</file>
+
+<file path=ppt/slides/slide28.xml><?xml version="1.0" encoding="utf-8"?>
+<p:sld xmlns:a="http://schemas.openxmlformats.org/drawingml/2006/main" xmlns:r="http://schemas.openxmlformats.org/officeDocument/2006/relationships" xmlns:p="http://schemas.openxmlformats.org/presentationml/2006/main">
+  <p:cSld>
+    <p:spTree>
+      <p:nvGrpSpPr>
+        <p:cNvPr id="1" name=""/>
+        <p:cNvGrpSpPr/>
+        <p:nvPr/>
+      </p:nvGrpSpPr>
+      <p:grpSpPr>
+        <a:xfrm>
+          <a:off x="0" y="0"/>
+          <a:ext cx="0" cy="0"/>
+          <a:chOff x="0" y="0"/>
+          <a:chExt cx="0" cy="0"/>
+        </a:xfrm>
+      </p:grpSpPr>
+      <p:sp>
+        <p:nvSpPr>
+          <p:cNvPr id="2" name="TextBox 1"/>
+          <p:cNvSpPr txBox="1"/>
+          <p:nvPr/>
+        </p:nvSpPr>
+        <p:spPr>
+          <a:xfrm>
+            <a:off x="438912" y="210312"/>
+            <a:ext cx="4572000" cy="228600"/>
+          </a:xfrm>
+          <a:prstGeom prst="rect">
+            <a:avLst/>
+          </a:prstGeom>
+          <a:noFill/>
+        </p:spPr>
+        <p:txBody>
+          <a:bodyPr wrap="square">
+            <a:spAutoFit/>
+          </a:bodyPr>
+          <a:lstStyle/>
+          <a:p>
+            <a:pPr algn="l">
+              <a:defRPr sz="800" b="1">
+                <a:solidFill>
+                  <a:srgbClr val="2563EB"/>
+                </a:solidFill>
+                <a:latin typeface="Aptos"/>
+              </a:defRPr>
+            </a:pPr>
+            <a:r>
+              <a:rPr lang="pt-BR" noProof="0" dirty="0"/>
+              <a:t>MÓDULO DE AFASTAMENTO E ELEGIBILIDADE</a:t>
+            </a:r>
+          </a:p>
+        </p:txBody>
+      </p:sp>
+      <p:sp>
+        <p:nvSpPr>
+          <p:cNvPr id="3" name="TextBox 2"/>
+          <p:cNvSpPr txBox="1"/>
+          <p:nvPr/>
+        </p:nvSpPr>
+        <p:spPr>
+          <a:xfrm>
+            <a:off x="438912" y="475488"/>
+            <a:ext cx="10972800" cy="411480"/>
+          </a:xfrm>
+          <a:prstGeom prst="rect">
+            <a:avLst/>
+          </a:prstGeom>
+          <a:noFill/>
+        </p:spPr>
+        <p:txBody>
+          <a:bodyPr wrap="square">
+            <a:spAutoFit/>
+          </a:bodyPr>
+          <a:lstStyle/>
+          <a:p>
+            <a:pPr algn="l">
+              <a:defRPr sz="2000" b="1">
+                <a:solidFill>
+                  <a:srgbClr val="161F2A"/>
+                </a:solidFill>
+                <a:latin typeface="Aptos"/>
+              </a:defRPr>
+            </a:pPr>
+            <a:r>
+              <a:rPr lang="pt-BR" noProof="0" dirty="0"/>
+              <a:t>Visualização dos afastamentos</a:t>
+            </a:r>
+          </a:p>
+        </p:txBody>
+      </p:sp>
+      <p:sp>
+        <p:nvSpPr>
+          <p:cNvPr id="4" name="TextBox 3"/>
+          <p:cNvSpPr txBox="1"/>
+          <p:nvPr/>
+        </p:nvSpPr>
+        <p:spPr>
+          <a:xfrm>
+            <a:off x="438912" y="868680"/>
+            <a:ext cx="10972800" cy="256032"/>
+          </a:xfrm>
+          <a:prstGeom prst="rect">
+            <a:avLst/>
+          </a:prstGeom>
+          <a:noFill/>
+        </p:spPr>
+        <p:txBody>
+          <a:bodyPr wrap="square">
+            <a:spAutoFit/>
+          </a:bodyPr>
+          <a:lstStyle/>
+          <a:p>
+            <a:pPr algn="l">
+              <a:defRPr sz="950" b="0">
+                <a:solidFill>
+                  <a:srgbClr val="5C6670"/>
+                </a:solidFill>
+                <a:latin typeface="Aptos"/>
+              </a:defRPr>
+            </a:pPr>
+            <a:r>
+              <a:rPr lang="pt-BR" noProof="0" dirty="0"/>
+              <a:t>Registro estruturado do operador, motivo e período.</a:t>
+            </a:r>
+          </a:p>
+        </p:txBody>
+      </p:sp>
+      <p:sp>
+        <p:nvSpPr>
+          <p:cNvPr id="5" name="Rectangle 4"/>
+          <p:cNvSpPr/>
+          <p:nvPr/>
+        </p:nvSpPr>
+        <p:spPr>
+          <a:xfrm>
+            <a:off x="438912" y="1197864"/>
+            <a:ext cx="11292840" cy="10972"/>
+          </a:xfrm>
+          <a:prstGeom prst="rect">
+            <a:avLst/>
+          </a:prstGeom>
+          <a:solidFill>
+            <a:srgbClr val="DCE0E6"/>
+          </a:solidFill>
+          <a:ln>
+            <a:noFill/>
+          </a:ln>
+        </p:spPr>
+        <p:style>
+          <a:lnRef idx="1">
+            <a:schemeClr val="accent1"/>
+          </a:lnRef>
+          <a:fillRef idx="3">
+            <a:schemeClr val="accent1"/>
+          </a:fillRef>
+          <a:effectRef idx="2">
+            <a:schemeClr val="accent1"/>
+          </a:effectRef>
+          <a:fontRef idx="minor">
+            <a:schemeClr val="lt1"/>
+          </a:fontRef>
+        </p:style>
+        <p:txBody>
+          <a:bodyPr rtlCol="0" anchor="ctr"/>
+          <a:lstStyle/>
+          <a:p>
+            <a:pPr algn="ctr"/>
+            <a:endParaRPr lang="pt-BR" noProof="0" dirty="0"/>
+          </a:p>
+        </p:txBody>
+      </p:sp>
+      <p:sp>
+        <p:nvSpPr>
+          <p:cNvPr id="6" name="Rectangle 5"/>
+          <p:cNvSpPr/>
+          <p:nvPr/>
+        </p:nvSpPr>
+        <p:spPr>
+          <a:xfrm>
+            <a:off x="521206" y="1362457"/>
+            <a:ext cx="7521617" cy="3448598"/>
+          </a:xfrm>
+          <a:prstGeom prst="rect">
+            <a:avLst/>
+          </a:prstGeom>
+          <a:solidFill>
+            <a:srgbClr val="FFFFFF"/>
+          </a:solidFill>
+          <a:ln>
+            <a:solidFill>
+              <a:srgbClr val="DCE0E6"/>
+            </a:solidFill>
+          </a:ln>
+        </p:spPr>
+        <p:style>
+          <a:lnRef idx="1">
+            <a:schemeClr val="accent1"/>
+          </a:lnRef>
+          <a:fillRef idx="3">
+            <a:schemeClr val="accent1"/>
+          </a:fillRef>
+          <a:effectRef idx="2">
+            <a:schemeClr val="accent1"/>
+          </a:effectRef>
+          <a:fontRef idx="minor">
+            <a:schemeClr val="lt1"/>
+          </a:fontRef>
+        </p:style>
+        <p:txBody>
+          <a:bodyPr rtlCol="0" anchor="ctr"/>
+          <a:lstStyle/>
+          <a:p>
+            <a:pPr algn="ctr"/>
+            <a:endParaRPr lang="pt-BR" noProof="0" dirty="0"/>
+          </a:p>
+        </p:txBody>
+      </p:sp>
+      <p:sp>
+        <p:nvSpPr>
+          <p:cNvPr id="8" name="TextBox 7"/>
+          <p:cNvSpPr txBox="1"/>
+          <p:nvPr/>
+        </p:nvSpPr>
+        <p:spPr>
+          <a:xfrm>
+            <a:off x="8275320" y="1554480"/>
+            <a:ext cx="3246120" cy="256032"/>
+          </a:xfrm>
+          <a:prstGeom prst="rect">
+            <a:avLst/>
+          </a:prstGeom>
+          <a:noFill/>
+        </p:spPr>
+        <p:txBody>
+          <a:bodyPr wrap="square">
+            <a:spAutoFit/>
+          </a:bodyPr>
+          <a:lstStyle/>
+          <a:p>
+            <a:pPr algn="l">
+              <a:defRPr sz="1050" b="1">
+                <a:solidFill>
+                  <a:srgbClr val="198754"/>
+                </a:solidFill>
+                <a:latin typeface="Aptos"/>
+              </a:defRPr>
+            </a:pPr>
+            <a:r>
+              <a:rPr lang="pt-BR" noProof="0" dirty="0"/>
+              <a:t>VISUALIZAÇÃO</a:t>
+            </a:r>
+          </a:p>
+        </p:txBody>
+      </p:sp>
+      <p:sp>
+        <p:nvSpPr>
+          <p:cNvPr id="9" name="TextBox 8"/>
+          <p:cNvSpPr txBox="1"/>
+          <p:nvPr/>
+        </p:nvSpPr>
+        <p:spPr>
+          <a:xfrm>
+            <a:off x="8275320" y="1901952"/>
+            <a:ext cx="3246120" cy="649922"/>
+          </a:xfrm>
+          <a:prstGeom prst="rect">
+            <a:avLst/>
+          </a:prstGeom>
+          <a:noFill/>
+        </p:spPr>
+        <p:txBody>
+          <a:bodyPr wrap="square">
+            <a:spAutoFit/>
+          </a:bodyPr>
+          <a:lstStyle/>
+          <a:p>
+            <a:pPr>
+              <a:spcAft>
+                <a:spcPts val="500"/>
+              </a:spcAft>
+              <a:defRPr sz="930">
+                <a:solidFill>
+                  <a:srgbClr val="161F2A"/>
+                </a:solidFill>
+                <a:latin typeface="Aptos"/>
+              </a:defRPr>
+            </a:pPr>
+            <a:r>
+              <a:rPr lang="pt-BR" noProof="0" dirty="0"/>
+              <a:t>• Pesquisa do operador por nome ou numérica.</a:t>
+            </a:r>
+          </a:p>
+          <a:p>
+            <a:pPr>
+              <a:spcAft>
+                <a:spcPts val="500"/>
+              </a:spcAft>
+              <a:defRPr sz="930">
+                <a:solidFill>
+                  <a:srgbClr val="161F2A"/>
+                </a:solidFill>
+                <a:latin typeface="Aptos"/>
+              </a:defRPr>
+            </a:pPr>
+            <a:r>
+              <a:rPr lang="pt-BR" noProof="0" dirty="0"/>
+              <a:t>• Filtros por períodos de tempo e seção.</a:t>
+            </a:r>
+          </a:p>
+          <a:p>
+            <a:pPr>
+              <a:spcAft>
+                <a:spcPts val="500"/>
+              </a:spcAft>
+              <a:defRPr sz="930">
+                <a:solidFill>
+                  <a:srgbClr val="161F2A"/>
+                </a:solidFill>
+                <a:latin typeface="Aptos"/>
+              </a:defRPr>
+            </a:pPr>
+            <a:r>
+              <a:rPr lang="pt-BR" noProof="0" dirty="0"/>
+              <a:t>• Filtro por tipo de afastamento.</a:t>
+            </a:r>
+          </a:p>
+        </p:txBody>
+      </p:sp>
+      <p:sp>
+        <p:nvSpPr>
+          <p:cNvPr id="10" name="TextBox 9"/>
+          <p:cNvSpPr txBox="1"/>
+          <p:nvPr/>
+        </p:nvSpPr>
+        <p:spPr>
+          <a:xfrm>
+            <a:off x="438912" y="6519672"/>
+            <a:ext cx="5120640" cy="164592"/>
+          </a:xfrm>
+          <a:prstGeom prst="rect">
+            <a:avLst/>
+          </a:prstGeom>
+          <a:noFill/>
+        </p:spPr>
+        <p:txBody>
+          <a:bodyPr wrap="square">
+            <a:spAutoFit/>
+          </a:bodyPr>
+          <a:lstStyle/>
+          <a:p>
+            <a:pPr algn="l">
+              <a:defRPr sz="700" b="0">
+                <a:solidFill>
+                  <a:srgbClr val="5C6670"/>
+                </a:solidFill>
+                <a:latin typeface="Aptos"/>
+              </a:defRPr>
+            </a:pPr>
+            <a:r>
+              <a:rPr lang="pt-BR" noProof="0" dirty="0"/>
+              <a:t>Op. 73 - 2026 - Divisão de Operações Especiais</a:t>
+            </a:r>
+          </a:p>
+        </p:txBody>
+      </p:sp>
+      <p:pic>
+        <p:nvPicPr>
+          <p:cNvPr id="13" name="Imagem 12">
+            <a:extLst>
+              <a:ext uri="{FF2B5EF4-FFF2-40B4-BE49-F238E27FC236}">
+                <a16:creationId xmlns:a16="http://schemas.microsoft.com/office/drawing/2014/main" id="{48B62AD3-B011-3370-2CC3-9606AAD9EDC3}"/>
+              </a:ext>
+            </a:extLst>
+          </p:cNvPr>
+          <p:cNvPicPr>
+            <a:picLocks noChangeAspect="1"/>
+          </p:cNvPicPr>
+          <p:nvPr/>
+        </p:nvPicPr>
+        <p:blipFill>
+          <a:blip r:embed="rId2"/>
+          <a:stretch>
+            <a:fillRect/>
+          </a:stretch>
+        </p:blipFill>
+        <p:spPr>
+          <a:xfrm>
+            <a:off x="521207" y="1362456"/>
+            <a:ext cx="7521617" cy="3448598"/>
+          </a:xfrm>
+          <a:prstGeom prst="rect">
+            <a:avLst/>
+          </a:prstGeom>
+        </p:spPr>
+      </p:pic>
     </p:spTree>
   </p:cSld>
   <p:clrMapOvr>

</xml_diff>